<commit_message>
PAUSED (task140): write-up figures at the precision every variant shares, re-read next
Precision-only change to blocks 1 and 2, accepted by the main session:
Critical Component 4 is the 1.208 reservable cores each guaranteed core
takes (109,492 dropped), Component 3 has no parentheses, the Final
Recommendation's coefficients read 2.94 and 0.208. Block 3 and the goldens
follow (the 2027 Q1 sheet's platform rows at the thousand, the cell-store
sheet's terms at 2.94 and 0.208, the slide's remainder as under 1,000). No
graded figure, file under target/ or figures.json value moved (three keys
added); checks.py asserts the shared precision under every converging
variant. freeze.py snapshot retaken after the change. The main session's
targeted re-read kept in leak_check_report.md.

Co-Authored-By: Claude Opus 5.5 <noreply@anthropic.com>
Claude-Session: https://claude.ai/code/session_01A6XcFx5t62c7gPi1bBKcVi
</commit_message>
<xml_diff>
--- a/task140/golden/c22_capacity_review_2027q1.pptx
+++ b/task140/golden/c22_capacity_review_2027q1.pptx
@@ -3754,7 +3754,7 @@
                         </a:defRPr>
                       </a:pPr>
                       <a:r>
-                        <a:t>594</a:t>
+                        <a:t>under 1,000</a:t>
                       </a:r>
                     </a:p>
                   </a:txBody>
@@ -3770,6 +3770,9 @@
                           <a:latin typeface="Calibri"/>
                         </a:defRPr>
                       </a:pPr>
+                      <a:r>
+                        <a:t>left after the guarantee (CS-3 5.2)</a:t>
+                      </a:r>
                     </a:p>
                   </a:txBody>
                   <a:tcPr/>

</xml_diff>